<commit_message>
custom layers - nonlinear approach
</commit_message>
<xml_diff>
--- a/8-26-2025.pptx
+++ b/8-26-2025.pptx
@@ -5,10 +5,10 @@
     <p:sldMasterId id="2147483668" r:id="rId4"/>
   </p:sldMasterIdLst>
   <p:notesMasterIdLst>
-    <p:notesMasterId r:id="rId11"/>
+    <p:notesMasterId r:id="rId16"/>
   </p:notesMasterIdLst>
   <p:handoutMasterIdLst>
-    <p:handoutMasterId r:id="rId12"/>
+    <p:handoutMasterId r:id="rId17"/>
   </p:handoutMasterIdLst>
   <p:sldIdLst>
     <p:sldId id="256" r:id="rId5"/>
@@ -17,6 +17,11 @@
     <p:sldId id="277" r:id="rId8"/>
     <p:sldId id="279" r:id="rId9"/>
     <p:sldId id="278" r:id="rId10"/>
+    <p:sldId id="281" r:id="rId11"/>
+    <p:sldId id="283" r:id="rId12"/>
+    <p:sldId id="285" r:id="rId13"/>
+    <p:sldId id="286" r:id="rId14"/>
+    <p:sldId id="284" r:id="rId15"/>
   </p:sldIdLst>
   <p:sldSz cx="12192000" cy="6858000"/>
   <p:notesSz cx="6858000" cy="9144000"/>
@@ -219,7 +224,7 @@
           <a:p>
             <a:fld id="{630E4E57-1CF6-4440-8310-3CBE926400C3}" type="datetimeFigureOut">
               <a:rPr lang="en-US" smtClean="0"/>
-              <a:t>8/25/2025</a:t>
+              <a:t>8/26/2025</a:t>
             </a:fld>
             <a:endParaRPr lang="en-US"/>
           </a:p>
@@ -384,7 +389,7 @@
           <a:p>
             <a:fld id="{4B78E97C-1779-4CEE-80D0-5BBB1AC4023D}" type="datetimeFigureOut">
               <a:rPr lang="en-US" smtClean="0"/>
-              <a:t>8/25/2025</a:t>
+              <a:t>8/26/2025</a:t>
             </a:fld>
             <a:endParaRPr lang="en-US"/>
           </a:p>
@@ -852,7 +857,7 @@
             <a:fld id="{A318C6E2-4AA5-436E-9815-715E9B2235FA}" type="datetime1">
               <a:rPr lang="en-US" smtClean="0"/>
               <a:pPr/>
-              <a:t>8/25/2025</a:t>
+              <a:t>8/26/2025</a:t>
             </a:fld>
             <a:endParaRPr lang="en-US" dirty="0"/>
           </a:p>
@@ -1656,7 +1661,7 @@
           <a:p>
             <a:fld id="{C17F432B-3FBE-4889-963D-BF97BFBB7D3F}" type="datetime1">
               <a:rPr lang="en-US" smtClean="0"/>
-              <a:t>8/25/2025</a:t>
+              <a:t>8/26/2025</a:t>
             </a:fld>
             <a:endParaRPr lang="en-US" dirty="0"/>
           </a:p>
@@ -1789,7 +1794,7 @@
           <a:p>
             <a:fld id="{310CCC04-1E76-41EE-A8AC-75AD85313D09}" type="datetime1">
               <a:rPr lang="en-US" smtClean="0"/>
-              <a:t>8/25/2025</a:t>
+              <a:t>8/26/2025</a:t>
             </a:fld>
             <a:endParaRPr lang="en-US" dirty="0"/>
           </a:p>
@@ -1895,7 +1900,7 @@
           <a:p>
             <a:fld id="{83974A9E-84AC-4661-9381-CC35B09E47F7}" type="datetime1">
               <a:rPr lang="en-US" smtClean="0"/>
-              <a:t>8/25/2025</a:t>
+              <a:t>8/26/2025</a:t>
             </a:fld>
             <a:endParaRPr lang="en-US" dirty="0"/>
           </a:p>
@@ -2007,7 +2012,7 @@
           <a:p>
             <a:fld id="{1E55829F-8847-4C2A-8DD0-690EAD78E53F}" type="datetime1">
               <a:rPr lang="en-US" smtClean="0"/>
-              <a:t>8/25/2025</a:t>
+              <a:t>8/26/2025</a:t>
             </a:fld>
             <a:endParaRPr lang="en-US" dirty="0"/>
           </a:p>
@@ -2444,7 +2449,7 @@
           <a:p>
             <a:fld id="{5FDFC970-B950-4395-A833-47227D4A68CA}" type="datetime1">
               <a:rPr lang="en-US" smtClean="0"/>
-              <a:t>8/25/2025</a:t>
+              <a:t>8/26/2025</a:t>
             </a:fld>
             <a:endParaRPr lang="en-US" dirty="0"/>
           </a:p>
@@ -3103,7 +3108,7 @@
           <a:p>
             <a:fld id="{5FDFC970-B950-4395-A833-47227D4A68CA}" type="datetime1">
               <a:rPr lang="en-US" smtClean="0"/>
-              <a:t>8/25/2025</a:t>
+              <a:t>8/26/2025</a:t>
             </a:fld>
             <a:endParaRPr lang="en-US" dirty="0"/>
           </a:p>
@@ -3789,7 +3794,7 @@
           <a:p>
             <a:fld id="{5FDFC970-B950-4395-A833-47227D4A68CA}" type="datetime1">
               <a:rPr lang="en-US" smtClean="0"/>
-              <a:t>8/25/2025</a:t>
+              <a:t>8/26/2025</a:t>
             </a:fld>
             <a:endParaRPr lang="en-US" dirty="0"/>
           </a:p>
@@ -4295,7 +4300,7 @@
             <a:fld id="{5FDFC970-B950-4395-A833-47227D4A68CA}" type="datetime1">
               <a:rPr lang="en-US" smtClean="0"/>
               <a:pPr/>
-              <a:t>8/25/2025</a:t>
+              <a:t>8/26/2025</a:t>
             </a:fld>
             <a:endParaRPr lang="en-US" dirty="0"/>
           </a:p>
@@ -4817,7 +4822,7 @@
             <a:fld id="{5FDFC970-B950-4395-A833-47227D4A68CA}" type="datetime1">
               <a:rPr lang="en-US" smtClean="0"/>
               <a:pPr/>
-              <a:t>8/25/2025</a:t>
+              <a:t>8/26/2025</a:t>
             </a:fld>
             <a:endParaRPr lang="en-US" dirty="0"/>
           </a:p>
@@ -5275,7 +5280,7 @@
           <a:p>
             <a:fld id="{75D660D7-90CE-4513-A3CE-C070B9421917}" type="datetime1">
               <a:rPr lang="en-US" smtClean="0"/>
-              <a:t>8/25/2025</a:t>
+              <a:t>8/26/2025</a:t>
             </a:fld>
             <a:endParaRPr lang="en-US" dirty="0"/>
           </a:p>
@@ -5860,7 +5865,7 @@
             <a:fld id="{A318C6E2-4AA5-436E-9815-715E9B2235FA}" type="datetime1">
               <a:rPr lang="en-US" smtClean="0"/>
               <a:pPr/>
-              <a:t>8/25/2025</a:t>
+              <a:t>8/26/2025</a:t>
             </a:fld>
             <a:endParaRPr lang="en-US" dirty="0"/>
           </a:p>
@@ -6373,7 +6378,7 @@
             <a:fld id="{0A368D4B-3D0A-49AB-8EA2-2DC8CB4594DB}" type="datetime1">
               <a:rPr lang="en-US" smtClean="0"/>
               <a:pPr/>
-              <a:t>8/25/2025</a:t>
+              <a:t>8/26/2025</a:t>
             </a:fld>
             <a:endParaRPr lang="en-US" dirty="0"/>
           </a:p>
@@ -6842,7 +6847,7 @@
             <a:fld id="{0A368D4B-3D0A-49AB-8EA2-2DC8CB4594DB}" type="datetime1">
               <a:rPr lang="en-US" smtClean="0"/>
               <a:pPr/>
-              <a:t>8/25/2025</a:t>
+              <a:t>8/26/2025</a:t>
             </a:fld>
             <a:endParaRPr lang="en-US" dirty="0"/>
           </a:p>
@@ -7533,7 +7538,7 @@
             <a:fld id="{A318C6E2-4AA5-436E-9815-715E9B2235FA}" type="datetime1">
               <a:rPr lang="en-US" smtClean="0"/>
               <a:pPr/>
-              <a:t>8/25/2025</a:t>
+              <a:t>8/26/2025</a:t>
             </a:fld>
             <a:endParaRPr lang="en-US" dirty="0"/>
           </a:p>
@@ -8116,7 +8121,7 @@
             <a:fld id="{A318C6E2-4AA5-436E-9815-715E9B2235FA}" type="datetime1">
               <a:rPr lang="en-US" smtClean="0"/>
               <a:pPr/>
-              <a:t>8/25/2025</a:t>
+              <a:t>8/26/2025</a:t>
             </a:fld>
             <a:endParaRPr lang="en-US" dirty="0"/>
           </a:p>
@@ -8646,7 +8651,7 @@
           <a:p>
             <a:fld id="{44D4B0C9-B47E-4B33-A656-C78D1805DA95}" type="datetime1">
               <a:rPr lang="en-US" smtClean="0"/>
-              <a:t>8/25/2025</a:t>
+              <a:t>8/26/2025</a:t>
             </a:fld>
             <a:endParaRPr lang="en-US" dirty="0"/>
           </a:p>
@@ -8938,7 +8943,7 @@
           <a:p>
             <a:fld id="{48C228CE-C572-4AF5-9728-AA6E475873DD}" type="datetime1">
               <a:rPr lang="en-US" smtClean="0"/>
-              <a:t>8/25/2025</a:t>
+              <a:t>8/26/2025</a:t>
             </a:fld>
             <a:endParaRPr lang="en-US" dirty="0"/>
           </a:p>
@@ -9242,7 +9247,7 @@
           <a:p>
             <a:fld id="{026D43AC-4B94-471D-A170-0D88FCD1FB54}" type="datetime1">
               <a:rPr lang="en-US" smtClean="0"/>
-              <a:t>8/25/2025</a:t>
+              <a:t>8/26/2025</a:t>
             </a:fld>
             <a:endParaRPr lang="en-US" dirty="0"/>
           </a:p>
@@ -9473,7 +9478,7 @@
           <a:p>
             <a:fld id="{72EFF9E2-52BD-4C8D-9C57-79F661DB94A1}" type="datetime1">
               <a:rPr lang="en-US" smtClean="0"/>
-              <a:t>8/25/2025</a:t>
+              <a:t>8/26/2025</a:t>
             </a:fld>
             <a:endParaRPr lang="en-US" dirty="0"/>
           </a:p>
@@ -10121,7 +10126,7 @@
           <a:p>
             <a:fld id="{081881F3-AB4F-4026-8B03-DBF7475676B1}" type="datetime1">
               <a:rPr lang="en-US" smtClean="0"/>
-              <a:t>8/25/2025</a:t>
+              <a:t>8/26/2025</a:t>
             </a:fld>
             <a:endParaRPr lang="en-US" dirty="0"/>
           </a:p>
@@ -10382,7 +10387,7 @@
           <a:p>
             <a:fld id="{5FDFC970-B950-4395-A833-47227D4A68CA}" type="datetime1">
               <a:rPr lang="en-US" smtClean="0"/>
-              <a:t>8/25/2025</a:t>
+              <a:t>8/26/2025</a:t>
             </a:fld>
             <a:endParaRPr lang="en-US" dirty="0"/>
           </a:p>
@@ -11203,6 +11208,318 @@
 </p:sld>
 </file>
 
+<file path=ppt/slides/slide10.xml><?xml version="1.0" encoding="utf-8"?>
+<p:sld xmlns:a="http://schemas.openxmlformats.org/drawingml/2006/main" xmlns:r="http://schemas.openxmlformats.org/officeDocument/2006/relationships" xmlns:p="http://schemas.openxmlformats.org/presentationml/2006/main">
+  <p:cSld>
+    <p:spTree>
+      <p:nvGrpSpPr>
+        <p:cNvPr id="1" name=""/>
+        <p:cNvGrpSpPr/>
+        <p:nvPr/>
+      </p:nvGrpSpPr>
+      <p:grpSpPr>
+        <a:xfrm>
+          <a:off x="0" y="0"/>
+          <a:ext cx="0" cy="0"/>
+          <a:chOff x="0" y="0"/>
+          <a:chExt cx="0" cy="0"/>
+        </a:xfrm>
+      </p:grpSpPr>
+      <p:sp>
+        <p:nvSpPr>
+          <p:cNvPr id="2" name="Title 1">
+            <a:extLst>
+              <a:ext uri="{FF2B5EF4-FFF2-40B4-BE49-F238E27FC236}">
+                <a16:creationId xmlns:a16="http://schemas.microsoft.com/office/drawing/2014/main" id="{158E73D5-5579-6906-D3A3-798409EE8A97}"/>
+              </a:ext>
+            </a:extLst>
+          </p:cNvPr>
+          <p:cNvSpPr>
+            <a:spLocks noGrp="1"/>
+          </p:cNvSpPr>
+          <p:nvPr>
+            <p:ph type="title"/>
+          </p:nvPr>
+        </p:nvSpPr>
+        <p:spPr/>
+        <p:txBody>
+          <a:bodyPr/>
+          <a:lstStyle/>
+          <a:p>
+            <a:r>
+              <a:rPr lang="en-US" dirty="0"/>
+              <a:t>200</a:t>
+            </a:r>
+          </a:p>
+        </p:txBody>
+      </p:sp>
+      <p:sp>
+        <p:nvSpPr>
+          <p:cNvPr id="4" name="Footer Placeholder 3">
+            <a:extLst>
+              <a:ext uri="{FF2B5EF4-FFF2-40B4-BE49-F238E27FC236}">
+                <a16:creationId xmlns:a16="http://schemas.microsoft.com/office/drawing/2014/main" id="{88C4CC19-F8CA-1920-E0B2-C46A0D3E27FC}"/>
+              </a:ext>
+            </a:extLst>
+          </p:cNvPr>
+          <p:cNvSpPr>
+            <a:spLocks noGrp="1"/>
+          </p:cNvSpPr>
+          <p:nvPr>
+            <p:ph type="ftr" sz="quarter" idx="11"/>
+          </p:nvPr>
+        </p:nvSpPr>
+        <p:spPr/>
+        <p:txBody>
+          <a:bodyPr/>
+          <a:lstStyle/>
+          <a:p>
+            <a:r>
+              <a:rPr lang="en-US"/>
+              <a:t>Progress Update</a:t>
+            </a:r>
+            <a:endParaRPr lang="en-US" dirty="0"/>
+          </a:p>
+        </p:txBody>
+      </p:sp>
+      <p:sp>
+        <p:nvSpPr>
+          <p:cNvPr id="5" name="Slide Number Placeholder 4">
+            <a:extLst>
+              <a:ext uri="{FF2B5EF4-FFF2-40B4-BE49-F238E27FC236}">
+                <a16:creationId xmlns:a16="http://schemas.microsoft.com/office/drawing/2014/main" id="{A470CAA2-6F83-E6AA-FFD1-26D803DFC80D}"/>
+              </a:ext>
+            </a:extLst>
+          </p:cNvPr>
+          <p:cNvSpPr>
+            <a:spLocks noGrp="1"/>
+          </p:cNvSpPr>
+          <p:nvPr>
+            <p:ph type="sldNum" sz="quarter" idx="12"/>
+          </p:nvPr>
+        </p:nvSpPr>
+        <p:spPr/>
+        <p:txBody>
+          <a:bodyPr/>
+          <a:lstStyle/>
+          <a:p>
+            <a:r>
+              <a:rPr lang="en-US"/>
+              <a:t>PAGE  </a:t>
+            </a:r>
+            <a:fld id="{93005692-73BE-493E-93AB-ECD6027A7652}" type="slidenum">
+              <a:rPr lang="en-US" smtClean="0"/>
+              <a:pPr/>
+              <a:t>10</a:t>
+            </a:fld>
+            <a:endParaRPr lang="en-US" dirty="0"/>
+          </a:p>
+        </p:txBody>
+      </p:sp>
+      <p:pic>
+        <p:nvPicPr>
+          <p:cNvPr id="13" name="Content Placeholder 12">
+            <a:extLst>
+              <a:ext uri="{FF2B5EF4-FFF2-40B4-BE49-F238E27FC236}">
+                <a16:creationId xmlns:a16="http://schemas.microsoft.com/office/drawing/2014/main" id="{E9FDDFAA-7AE0-5AA8-8723-91C1305C83ED}"/>
+              </a:ext>
+            </a:extLst>
+          </p:cNvPr>
+          <p:cNvPicPr>
+            <a:picLocks noGrp="1" noChangeAspect="1"/>
+          </p:cNvPicPr>
+          <p:nvPr>
+            <p:ph idx="1"/>
+          </p:nvPr>
+        </p:nvPicPr>
+        <p:blipFill>
+          <a:blip r:embed="rId2"/>
+          <a:stretch>
+            <a:fillRect/>
+          </a:stretch>
+        </p:blipFill>
+        <p:spPr>
+          <a:xfrm>
+            <a:off x="2598340" y="1412875"/>
+            <a:ext cx="6893719" cy="4595813"/>
+          </a:xfrm>
+          <a:prstGeom prst="rect">
+            <a:avLst/>
+          </a:prstGeom>
+        </p:spPr>
+      </p:pic>
+    </p:spTree>
+    <p:extLst>
+      <p:ext uri="{BB962C8B-B14F-4D97-AF65-F5344CB8AC3E}">
+        <p14:creationId xmlns:p14="http://schemas.microsoft.com/office/powerpoint/2010/main" val="2978544565"/>
+      </p:ext>
+    </p:extLst>
+  </p:cSld>
+  <p:clrMapOvr>
+    <a:masterClrMapping/>
+  </p:clrMapOvr>
+  <p:transition spd="slow">
+    <p:push dir="u"/>
+  </p:transition>
+</p:sld>
+</file>
+
+<file path=ppt/slides/slide11.xml><?xml version="1.0" encoding="utf-8"?>
+<p:sld xmlns:a="http://schemas.openxmlformats.org/drawingml/2006/main" xmlns:r="http://schemas.openxmlformats.org/officeDocument/2006/relationships" xmlns:p="http://schemas.openxmlformats.org/presentationml/2006/main">
+  <p:cSld>
+    <p:spTree>
+      <p:nvGrpSpPr>
+        <p:cNvPr id="1" name=""/>
+        <p:cNvGrpSpPr/>
+        <p:nvPr/>
+      </p:nvGrpSpPr>
+      <p:grpSpPr>
+        <a:xfrm>
+          <a:off x="0" y="0"/>
+          <a:ext cx="0" cy="0"/>
+          <a:chOff x="0" y="0"/>
+          <a:chExt cx="0" cy="0"/>
+        </a:xfrm>
+      </p:grpSpPr>
+      <p:sp>
+        <p:nvSpPr>
+          <p:cNvPr id="2" name="Title 1">
+            <a:extLst>
+              <a:ext uri="{FF2B5EF4-FFF2-40B4-BE49-F238E27FC236}">
+                <a16:creationId xmlns:a16="http://schemas.microsoft.com/office/drawing/2014/main" id="{BC168DEA-BE6F-6100-92CC-CFC08D050667}"/>
+              </a:ext>
+            </a:extLst>
+          </p:cNvPr>
+          <p:cNvSpPr>
+            <a:spLocks noGrp="1"/>
+          </p:cNvSpPr>
+          <p:nvPr>
+            <p:ph type="title"/>
+          </p:nvPr>
+        </p:nvSpPr>
+        <p:spPr/>
+        <p:txBody>
+          <a:bodyPr/>
+          <a:lstStyle/>
+          <a:p>
+            <a:r>
+              <a:rPr lang="en-US" dirty="0"/>
+              <a:t>200</a:t>
+            </a:r>
+          </a:p>
+        </p:txBody>
+      </p:sp>
+      <p:pic>
+        <p:nvPicPr>
+          <p:cNvPr id="7" name="Content Placeholder 6">
+            <a:extLst>
+              <a:ext uri="{FF2B5EF4-FFF2-40B4-BE49-F238E27FC236}">
+                <a16:creationId xmlns:a16="http://schemas.microsoft.com/office/drawing/2014/main" id="{68B3CF50-6C1C-2F84-749B-2D7DEB13B720}"/>
+              </a:ext>
+            </a:extLst>
+          </p:cNvPr>
+          <p:cNvPicPr>
+            <a:picLocks noGrp="1" noChangeAspect="1"/>
+          </p:cNvPicPr>
+          <p:nvPr>
+            <p:ph idx="1"/>
+          </p:nvPr>
+        </p:nvPicPr>
+        <p:blipFill>
+          <a:blip r:embed="rId2"/>
+          <a:stretch>
+            <a:fillRect/>
+          </a:stretch>
+        </p:blipFill>
+        <p:spPr>
+          <a:xfrm>
+            <a:off x="3226496" y="1412875"/>
+            <a:ext cx="5637408" cy="4595813"/>
+          </a:xfrm>
+          <a:prstGeom prst="rect">
+            <a:avLst/>
+          </a:prstGeom>
+        </p:spPr>
+      </p:pic>
+      <p:sp>
+        <p:nvSpPr>
+          <p:cNvPr id="4" name="Footer Placeholder 3">
+            <a:extLst>
+              <a:ext uri="{FF2B5EF4-FFF2-40B4-BE49-F238E27FC236}">
+                <a16:creationId xmlns:a16="http://schemas.microsoft.com/office/drawing/2014/main" id="{B501778A-CD13-089A-082B-7E6480E5C96D}"/>
+              </a:ext>
+            </a:extLst>
+          </p:cNvPr>
+          <p:cNvSpPr>
+            <a:spLocks noGrp="1"/>
+          </p:cNvSpPr>
+          <p:nvPr>
+            <p:ph type="ftr" sz="quarter" idx="11"/>
+          </p:nvPr>
+        </p:nvSpPr>
+        <p:spPr/>
+        <p:txBody>
+          <a:bodyPr/>
+          <a:lstStyle/>
+          <a:p>
+            <a:r>
+              <a:rPr lang="en-US"/>
+              <a:t>Progress Update</a:t>
+            </a:r>
+            <a:endParaRPr lang="en-US" dirty="0"/>
+          </a:p>
+        </p:txBody>
+      </p:sp>
+      <p:sp>
+        <p:nvSpPr>
+          <p:cNvPr id="5" name="Slide Number Placeholder 4">
+            <a:extLst>
+              <a:ext uri="{FF2B5EF4-FFF2-40B4-BE49-F238E27FC236}">
+                <a16:creationId xmlns:a16="http://schemas.microsoft.com/office/drawing/2014/main" id="{58A1E203-9233-4FC2-A37B-CC2CE90689F1}"/>
+              </a:ext>
+            </a:extLst>
+          </p:cNvPr>
+          <p:cNvSpPr>
+            <a:spLocks noGrp="1"/>
+          </p:cNvSpPr>
+          <p:nvPr>
+            <p:ph type="sldNum" sz="quarter" idx="12"/>
+          </p:nvPr>
+        </p:nvSpPr>
+        <p:spPr/>
+        <p:txBody>
+          <a:bodyPr/>
+          <a:lstStyle/>
+          <a:p>
+            <a:r>
+              <a:rPr lang="en-US"/>
+              <a:t>PAGE  </a:t>
+            </a:r>
+            <a:fld id="{93005692-73BE-493E-93AB-ECD6027A7652}" type="slidenum">
+              <a:rPr lang="en-US" smtClean="0"/>
+              <a:pPr/>
+              <a:t>11</a:t>
+            </a:fld>
+            <a:endParaRPr lang="en-US" dirty="0"/>
+          </a:p>
+        </p:txBody>
+      </p:sp>
+    </p:spTree>
+    <p:extLst>
+      <p:ext uri="{BB962C8B-B14F-4D97-AF65-F5344CB8AC3E}">
+        <p14:creationId xmlns:p14="http://schemas.microsoft.com/office/powerpoint/2010/main" val="3783670050"/>
+      </p:ext>
+    </p:extLst>
+  </p:cSld>
+  <p:clrMapOvr>
+    <a:masterClrMapping/>
+  </p:clrMapOvr>
+  <p:transition spd="slow">
+    <p:push dir="u"/>
+  </p:transition>
+</p:sld>
+</file>
+
 <file path=ppt/slides/slide2.xml><?xml version="1.0" encoding="utf-8"?>
 <p:sld xmlns:a="http://schemas.openxmlformats.org/drawingml/2006/main" xmlns:r="http://schemas.openxmlformats.org/officeDocument/2006/relationships" xmlns:p="http://schemas.openxmlformats.org/presentationml/2006/main">
   <p:cSld>
@@ -11965,6 +12282,474 @@
     <p:extLst>
       <p:ext uri="{BB962C8B-B14F-4D97-AF65-F5344CB8AC3E}">
         <p14:creationId xmlns:p14="http://schemas.microsoft.com/office/powerpoint/2010/main" val="370774595"/>
+      </p:ext>
+    </p:extLst>
+  </p:cSld>
+  <p:clrMapOvr>
+    <a:masterClrMapping/>
+  </p:clrMapOvr>
+  <p:transition spd="slow">
+    <p:push dir="u"/>
+  </p:transition>
+</p:sld>
+</file>
+
+<file path=ppt/slides/slide7.xml><?xml version="1.0" encoding="utf-8"?>
+<p:sld xmlns:a="http://schemas.openxmlformats.org/drawingml/2006/main" xmlns:r="http://schemas.openxmlformats.org/officeDocument/2006/relationships" xmlns:p="http://schemas.openxmlformats.org/presentationml/2006/main">
+  <p:cSld>
+    <p:spTree>
+      <p:nvGrpSpPr>
+        <p:cNvPr id="1" name=""/>
+        <p:cNvGrpSpPr/>
+        <p:nvPr/>
+      </p:nvGrpSpPr>
+      <p:grpSpPr>
+        <a:xfrm>
+          <a:off x="0" y="0"/>
+          <a:ext cx="0" cy="0"/>
+          <a:chOff x="0" y="0"/>
+          <a:chExt cx="0" cy="0"/>
+        </a:xfrm>
+      </p:grpSpPr>
+      <p:sp>
+        <p:nvSpPr>
+          <p:cNvPr id="2" name="Title 1">
+            <a:extLst>
+              <a:ext uri="{FF2B5EF4-FFF2-40B4-BE49-F238E27FC236}">
+                <a16:creationId xmlns:a16="http://schemas.microsoft.com/office/drawing/2014/main" id="{42F67E97-0FCD-0177-3252-BD7DCD571AAF}"/>
+              </a:ext>
+            </a:extLst>
+          </p:cNvPr>
+          <p:cNvSpPr>
+            <a:spLocks noGrp="1"/>
+          </p:cNvSpPr>
+          <p:nvPr>
+            <p:ph type="title"/>
+          </p:nvPr>
+        </p:nvSpPr>
+        <p:spPr/>
+        <p:txBody>
+          <a:bodyPr/>
+          <a:lstStyle/>
+          <a:p>
+            <a:r>
+              <a:rPr lang="en-US" dirty="0"/>
+              <a:t>500</a:t>
+            </a:r>
+          </a:p>
+        </p:txBody>
+      </p:sp>
+      <p:pic>
+        <p:nvPicPr>
+          <p:cNvPr id="7" name="Content Placeholder 6">
+            <a:extLst>
+              <a:ext uri="{FF2B5EF4-FFF2-40B4-BE49-F238E27FC236}">
+                <a16:creationId xmlns:a16="http://schemas.microsoft.com/office/drawing/2014/main" id="{2BF8B298-578D-933F-0B53-BA65DAF0DA89}"/>
+              </a:ext>
+            </a:extLst>
+          </p:cNvPr>
+          <p:cNvPicPr>
+            <a:picLocks noGrp="1" noChangeAspect="1"/>
+          </p:cNvPicPr>
+          <p:nvPr>
+            <p:ph idx="1"/>
+          </p:nvPr>
+        </p:nvPicPr>
+        <p:blipFill>
+          <a:blip r:embed="rId2"/>
+          <a:stretch>
+            <a:fillRect/>
+          </a:stretch>
+        </p:blipFill>
+        <p:spPr>
+          <a:xfrm>
+            <a:off x="2649063" y="1591173"/>
+            <a:ext cx="6792273" cy="4239217"/>
+          </a:xfrm>
+          <a:prstGeom prst="rect">
+            <a:avLst/>
+          </a:prstGeom>
+        </p:spPr>
+      </p:pic>
+      <p:sp>
+        <p:nvSpPr>
+          <p:cNvPr id="4" name="Footer Placeholder 3">
+            <a:extLst>
+              <a:ext uri="{FF2B5EF4-FFF2-40B4-BE49-F238E27FC236}">
+                <a16:creationId xmlns:a16="http://schemas.microsoft.com/office/drawing/2014/main" id="{BD919EE8-84B4-019E-028E-C6BF01E44A63}"/>
+              </a:ext>
+            </a:extLst>
+          </p:cNvPr>
+          <p:cNvSpPr>
+            <a:spLocks noGrp="1"/>
+          </p:cNvSpPr>
+          <p:nvPr>
+            <p:ph type="ftr" sz="quarter" idx="11"/>
+          </p:nvPr>
+        </p:nvSpPr>
+        <p:spPr/>
+        <p:txBody>
+          <a:bodyPr/>
+          <a:lstStyle/>
+          <a:p>
+            <a:r>
+              <a:rPr lang="en-US"/>
+              <a:t>Progress Update</a:t>
+            </a:r>
+            <a:endParaRPr lang="en-US" dirty="0"/>
+          </a:p>
+        </p:txBody>
+      </p:sp>
+      <p:sp>
+        <p:nvSpPr>
+          <p:cNvPr id="5" name="Slide Number Placeholder 4">
+            <a:extLst>
+              <a:ext uri="{FF2B5EF4-FFF2-40B4-BE49-F238E27FC236}">
+                <a16:creationId xmlns:a16="http://schemas.microsoft.com/office/drawing/2014/main" id="{9448914C-EDB3-8E7B-4274-A52D43BEB60F}"/>
+              </a:ext>
+            </a:extLst>
+          </p:cNvPr>
+          <p:cNvSpPr>
+            <a:spLocks noGrp="1"/>
+          </p:cNvSpPr>
+          <p:nvPr>
+            <p:ph type="sldNum" sz="quarter" idx="12"/>
+          </p:nvPr>
+        </p:nvSpPr>
+        <p:spPr/>
+        <p:txBody>
+          <a:bodyPr/>
+          <a:lstStyle/>
+          <a:p>
+            <a:r>
+              <a:rPr lang="en-US"/>
+              <a:t>PAGE  </a:t>
+            </a:r>
+            <a:fld id="{93005692-73BE-493E-93AB-ECD6027A7652}" type="slidenum">
+              <a:rPr lang="en-US" smtClean="0"/>
+              <a:pPr/>
+              <a:t>7</a:t>
+            </a:fld>
+            <a:endParaRPr lang="en-US" dirty="0"/>
+          </a:p>
+        </p:txBody>
+      </p:sp>
+    </p:spTree>
+    <p:extLst>
+      <p:ext uri="{BB962C8B-B14F-4D97-AF65-F5344CB8AC3E}">
+        <p14:creationId xmlns:p14="http://schemas.microsoft.com/office/powerpoint/2010/main" val="3073406032"/>
+      </p:ext>
+    </p:extLst>
+  </p:cSld>
+  <p:clrMapOvr>
+    <a:masterClrMapping/>
+  </p:clrMapOvr>
+  <p:transition spd="slow">
+    <p:push dir="u"/>
+  </p:transition>
+</p:sld>
+</file>
+
+<file path=ppt/slides/slide8.xml><?xml version="1.0" encoding="utf-8"?>
+<p:sld xmlns:a="http://schemas.openxmlformats.org/drawingml/2006/main" xmlns:r="http://schemas.openxmlformats.org/officeDocument/2006/relationships" xmlns:p="http://schemas.openxmlformats.org/presentationml/2006/main">
+  <p:cSld>
+    <p:spTree>
+      <p:nvGrpSpPr>
+        <p:cNvPr id="1" name=""/>
+        <p:cNvGrpSpPr/>
+        <p:nvPr/>
+      </p:nvGrpSpPr>
+      <p:grpSpPr>
+        <a:xfrm>
+          <a:off x="0" y="0"/>
+          <a:ext cx="0" cy="0"/>
+          <a:chOff x="0" y="0"/>
+          <a:chExt cx="0" cy="0"/>
+        </a:xfrm>
+      </p:grpSpPr>
+      <p:sp>
+        <p:nvSpPr>
+          <p:cNvPr id="2" name="Title 1">
+            <a:extLst>
+              <a:ext uri="{FF2B5EF4-FFF2-40B4-BE49-F238E27FC236}">
+                <a16:creationId xmlns:a16="http://schemas.microsoft.com/office/drawing/2014/main" id="{30444296-EB31-FC02-D757-CFDE5E918C1A}"/>
+              </a:ext>
+            </a:extLst>
+          </p:cNvPr>
+          <p:cNvSpPr>
+            <a:spLocks noGrp="1"/>
+          </p:cNvSpPr>
+          <p:nvPr>
+            <p:ph type="title"/>
+          </p:nvPr>
+        </p:nvSpPr>
+        <p:spPr/>
+        <p:txBody>
+          <a:bodyPr/>
+          <a:lstStyle/>
+          <a:p>
+            <a:r>
+              <a:rPr lang="en-US" dirty="0"/>
+              <a:t>500</a:t>
+            </a:r>
+          </a:p>
+        </p:txBody>
+      </p:sp>
+      <p:pic>
+        <p:nvPicPr>
+          <p:cNvPr id="7" name="Content Placeholder 6">
+            <a:extLst>
+              <a:ext uri="{FF2B5EF4-FFF2-40B4-BE49-F238E27FC236}">
+                <a16:creationId xmlns:a16="http://schemas.microsoft.com/office/drawing/2014/main" id="{BC425454-8B5D-FBC7-CFE9-57031704C83F}"/>
+              </a:ext>
+            </a:extLst>
+          </p:cNvPr>
+          <p:cNvPicPr>
+            <a:picLocks noGrp="1" noChangeAspect="1"/>
+          </p:cNvPicPr>
+          <p:nvPr>
+            <p:ph idx="1"/>
+          </p:nvPr>
+        </p:nvPicPr>
+        <p:blipFill>
+          <a:blip r:embed="rId2"/>
+          <a:stretch>
+            <a:fillRect/>
+          </a:stretch>
+        </p:blipFill>
+        <p:spPr>
+          <a:xfrm>
+            <a:off x="3030116" y="1472094"/>
+            <a:ext cx="6030167" cy="4477375"/>
+          </a:xfrm>
+          <a:prstGeom prst="rect">
+            <a:avLst/>
+          </a:prstGeom>
+        </p:spPr>
+      </p:pic>
+      <p:sp>
+        <p:nvSpPr>
+          <p:cNvPr id="4" name="Footer Placeholder 3">
+            <a:extLst>
+              <a:ext uri="{FF2B5EF4-FFF2-40B4-BE49-F238E27FC236}">
+                <a16:creationId xmlns:a16="http://schemas.microsoft.com/office/drawing/2014/main" id="{0ED9B7A3-3EE2-C59E-3C98-C995C9A5C365}"/>
+              </a:ext>
+            </a:extLst>
+          </p:cNvPr>
+          <p:cNvSpPr>
+            <a:spLocks noGrp="1"/>
+          </p:cNvSpPr>
+          <p:nvPr>
+            <p:ph type="ftr" sz="quarter" idx="11"/>
+          </p:nvPr>
+        </p:nvSpPr>
+        <p:spPr/>
+        <p:txBody>
+          <a:bodyPr/>
+          <a:lstStyle/>
+          <a:p>
+            <a:r>
+              <a:rPr lang="en-US"/>
+              <a:t>Progress Update</a:t>
+            </a:r>
+            <a:endParaRPr lang="en-US" dirty="0"/>
+          </a:p>
+        </p:txBody>
+      </p:sp>
+      <p:sp>
+        <p:nvSpPr>
+          <p:cNvPr id="5" name="Slide Number Placeholder 4">
+            <a:extLst>
+              <a:ext uri="{FF2B5EF4-FFF2-40B4-BE49-F238E27FC236}">
+                <a16:creationId xmlns:a16="http://schemas.microsoft.com/office/drawing/2014/main" id="{D4E29E14-B5E4-48F1-D8B1-098614DC906B}"/>
+              </a:ext>
+            </a:extLst>
+          </p:cNvPr>
+          <p:cNvSpPr>
+            <a:spLocks noGrp="1"/>
+          </p:cNvSpPr>
+          <p:nvPr>
+            <p:ph type="sldNum" sz="quarter" idx="12"/>
+          </p:nvPr>
+        </p:nvSpPr>
+        <p:spPr/>
+        <p:txBody>
+          <a:bodyPr/>
+          <a:lstStyle/>
+          <a:p>
+            <a:r>
+              <a:rPr lang="en-US"/>
+              <a:t>PAGE  </a:t>
+            </a:r>
+            <a:fld id="{93005692-73BE-493E-93AB-ECD6027A7652}" type="slidenum">
+              <a:rPr lang="en-US" smtClean="0"/>
+              <a:pPr/>
+              <a:t>8</a:t>
+            </a:fld>
+            <a:endParaRPr lang="en-US" dirty="0"/>
+          </a:p>
+        </p:txBody>
+      </p:sp>
+    </p:spTree>
+    <p:extLst>
+      <p:ext uri="{BB962C8B-B14F-4D97-AF65-F5344CB8AC3E}">
+        <p14:creationId xmlns:p14="http://schemas.microsoft.com/office/powerpoint/2010/main" val="4051816639"/>
+      </p:ext>
+    </p:extLst>
+  </p:cSld>
+  <p:clrMapOvr>
+    <a:masterClrMapping/>
+  </p:clrMapOvr>
+  <p:transition spd="slow">
+    <p:push dir="u"/>
+  </p:transition>
+</p:sld>
+</file>
+
+<file path=ppt/slides/slide9.xml><?xml version="1.0" encoding="utf-8"?>
+<p:sld xmlns:a="http://schemas.openxmlformats.org/drawingml/2006/main" xmlns:r="http://schemas.openxmlformats.org/officeDocument/2006/relationships" xmlns:p="http://schemas.openxmlformats.org/presentationml/2006/main">
+  <p:cSld>
+    <p:spTree>
+      <p:nvGrpSpPr>
+        <p:cNvPr id="1" name=""/>
+        <p:cNvGrpSpPr/>
+        <p:nvPr/>
+      </p:nvGrpSpPr>
+      <p:grpSpPr>
+        <a:xfrm>
+          <a:off x="0" y="0"/>
+          <a:ext cx="0" cy="0"/>
+          <a:chOff x="0" y="0"/>
+          <a:chExt cx="0" cy="0"/>
+        </a:xfrm>
+      </p:grpSpPr>
+      <p:sp>
+        <p:nvSpPr>
+          <p:cNvPr id="2" name="Title 1">
+            <a:extLst>
+              <a:ext uri="{FF2B5EF4-FFF2-40B4-BE49-F238E27FC236}">
+                <a16:creationId xmlns:a16="http://schemas.microsoft.com/office/drawing/2014/main" id="{6DAD1CD8-F08A-6561-5A38-97B615784B5A}"/>
+              </a:ext>
+            </a:extLst>
+          </p:cNvPr>
+          <p:cNvSpPr>
+            <a:spLocks noGrp="1"/>
+          </p:cNvSpPr>
+          <p:nvPr>
+            <p:ph type="title"/>
+          </p:nvPr>
+        </p:nvSpPr>
+        <p:spPr/>
+        <p:txBody>
+          <a:bodyPr/>
+          <a:lstStyle/>
+          <a:p>
+            <a:r>
+              <a:rPr lang="en-US" dirty="0"/>
+              <a:t>200</a:t>
+            </a:r>
+          </a:p>
+        </p:txBody>
+      </p:sp>
+      <p:sp>
+        <p:nvSpPr>
+          <p:cNvPr id="4" name="Footer Placeholder 3">
+            <a:extLst>
+              <a:ext uri="{FF2B5EF4-FFF2-40B4-BE49-F238E27FC236}">
+                <a16:creationId xmlns:a16="http://schemas.microsoft.com/office/drawing/2014/main" id="{2C36460C-4638-9147-1FC3-D9400819B173}"/>
+              </a:ext>
+            </a:extLst>
+          </p:cNvPr>
+          <p:cNvSpPr>
+            <a:spLocks noGrp="1"/>
+          </p:cNvSpPr>
+          <p:nvPr>
+            <p:ph type="ftr" sz="quarter" idx="11"/>
+          </p:nvPr>
+        </p:nvSpPr>
+        <p:spPr/>
+        <p:txBody>
+          <a:bodyPr/>
+          <a:lstStyle/>
+          <a:p>
+            <a:r>
+              <a:rPr lang="en-US"/>
+              <a:t>Progress Update</a:t>
+            </a:r>
+            <a:endParaRPr lang="en-US" dirty="0"/>
+          </a:p>
+        </p:txBody>
+      </p:sp>
+      <p:sp>
+        <p:nvSpPr>
+          <p:cNvPr id="5" name="Slide Number Placeholder 4">
+            <a:extLst>
+              <a:ext uri="{FF2B5EF4-FFF2-40B4-BE49-F238E27FC236}">
+                <a16:creationId xmlns:a16="http://schemas.microsoft.com/office/drawing/2014/main" id="{264CB8F5-6524-F201-D97B-0ADEB3D735A6}"/>
+              </a:ext>
+            </a:extLst>
+          </p:cNvPr>
+          <p:cNvSpPr>
+            <a:spLocks noGrp="1"/>
+          </p:cNvSpPr>
+          <p:nvPr>
+            <p:ph type="sldNum" sz="quarter" idx="12"/>
+          </p:nvPr>
+        </p:nvSpPr>
+        <p:spPr/>
+        <p:txBody>
+          <a:bodyPr/>
+          <a:lstStyle/>
+          <a:p>
+            <a:r>
+              <a:rPr lang="en-US"/>
+              <a:t>PAGE  </a:t>
+            </a:r>
+            <a:fld id="{93005692-73BE-493E-93AB-ECD6027A7652}" type="slidenum">
+              <a:rPr lang="en-US" smtClean="0"/>
+              <a:pPr/>
+              <a:t>9</a:t>
+            </a:fld>
+            <a:endParaRPr lang="en-US" dirty="0"/>
+          </a:p>
+        </p:txBody>
+      </p:sp>
+      <p:pic>
+        <p:nvPicPr>
+          <p:cNvPr id="17" name="Content Placeholder 16">
+            <a:extLst>
+              <a:ext uri="{FF2B5EF4-FFF2-40B4-BE49-F238E27FC236}">
+                <a16:creationId xmlns:a16="http://schemas.microsoft.com/office/drawing/2014/main" id="{6A9705BB-BD58-0550-DDB7-4590354D6E83}"/>
+              </a:ext>
+            </a:extLst>
+          </p:cNvPr>
+          <p:cNvPicPr>
+            <a:picLocks noGrp="1" noChangeAspect="1"/>
+          </p:cNvPicPr>
+          <p:nvPr>
+            <p:ph idx="1"/>
+          </p:nvPr>
+        </p:nvPicPr>
+        <p:blipFill>
+          <a:blip r:embed="rId2"/>
+          <a:stretch>
+            <a:fillRect/>
+          </a:stretch>
+        </p:blipFill>
+        <p:spPr>
+          <a:xfrm>
+            <a:off x="2537153" y="1412875"/>
+            <a:ext cx="7016093" cy="4595813"/>
+          </a:xfrm>
+          <a:prstGeom prst="rect">
+            <a:avLst/>
+          </a:prstGeom>
+        </p:spPr>
+      </p:pic>
+    </p:spTree>
+    <p:extLst>
+      <p:ext uri="{BB962C8B-B14F-4D97-AF65-F5344CB8AC3E}">
+        <p14:creationId xmlns:p14="http://schemas.microsoft.com/office/powerpoint/2010/main" val="1675952964"/>
       </p:ext>
     </p:extLst>
   </p:cSld>
@@ -12735,26 +13520,6 @@
 </file>
 
 <file path=customXml/item1.xml><?xml version="1.0" encoding="utf-8"?>
-<?mso-contentType ?>
-<FormTemplates xmlns="http://schemas.microsoft.com/sharepoint/v3/contenttype/forms">
-  <Display>DocumentLibraryForm</Display>
-  <Edit>DocumentLibraryForm</Edit>
-  <New>DocumentLibraryForm</New>
-</FormTemplates>
-</file>
-
-<file path=customXml/item2.xml><?xml version="1.0" encoding="utf-8"?>
-<p:properties xmlns:p="http://schemas.microsoft.com/office/2006/metadata/properties" xmlns:xsi="http://www.w3.org/2001/XMLSchema-instance" xmlns:pc="http://schemas.microsoft.com/office/infopath/2007/PartnerControls">
-  <documentManagement>
-    <lcf76f155ced4ddcb4097134ff3c332f xmlns="5d8f0207-1964-4a5e-9049-2927796093eb">
-      <Terms xmlns="http://schemas.microsoft.com/office/infopath/2007/PartnerControls"/>
-    </lcf76f155ced4ddcb4097134ff3c332f>
-    <TaxCatchAll xmlns="9bed8fe0-fd4c-4f92-9936-a2497f3396f6" xsi:nil="true"/>
-  </documentManagement>
-</p:properties>
-</file>
-
-<file path=customXml/item3.xml><?xml version="1.0" encoding="utf-8"?>
 <ct:contentTypeSchema xmlns:ct="http://schemas.microsoft.com/office/2006/metadata/contentType" xmlns:ma="http://schemas.microsoft.com/office/2006/metadata/properties/metaAttributes" ct:_="" ma:_="" ma:contentTypeName="Document" ma:contentTypeID="0x0101009535D3CEC2F76A4CA1EC3507E2D03D36" ma:contentTypeVersion="16" ma:contentTypeDescription="Create a new document." ma:contentTypeScope="" ma:versionID="bb97bee70b1606bbb700640dacabe47f">
   <xsd:schema xmlns:xsd="http://www.w3.org/2001/XMLSchema" xmlns:xs="http://www.w3.org/2001/XMLSchema" xmlns:p="http://schemas.microsoft.com/office/2006/metadata/properties" xmlns:ns2="9bed8fe0-fd4c-4f92-9936-a2497f3396f6" xmlns:ns3="5d8f0207-1964-4a5e-9049-2927796093eb" targetNamespace="http://schemas.microsoft.com/office/2006/metadata/properties" ma:root="true" ma:fieldsID="5de26a37e5c2406e777d4ddd47cd8e40" ns2:_="" ns3:_="">
     <xsd:import namespace="9bed8fe0-fd4c-4f92-9936-a2497f3396f6"/>
@@ -12991,26 +13756,27 @@
 </ct:contentTypeSchema>
 </file>
 
-<file path=customXml/itemProps1.xml><?xml version="1.0" encoding="utf-8"?>
-<ds:datastoreItem xmlns:ds="http://schemas.openxmlformats.org/officeDocument/2006/customXml" ds:itemID="{87F4C4DB-07ED-49AD-9A79-4094EE45E6E4}">
-  <ds:schemaRefs>
-    <ds:schemaRef ds:uri="http://schemas.microsoft.com/sharepoint/v3/contenttype/forms"/>
-  </ds:schemaRefs>
-</ds:datastoreItem>
+<file path=customXml/item2.xml><?xml version="1.0" encoding="utf-8"?>
+<p:properties xmlns:p="http://schemas.microsoft.com/office/2006/metadata/properties" xmlns:xsi="http://www.w3.org/2001/XMLSchema-instance" xmlns:pc="http://schemas.microsoft.com/office/infopath/2007/PartnerControls">
+  <documentManagement>
+    <lcf76f155ced4ddcb4097134ff3c332f xmlns="5d8f0207-1964-4a5e-9049-2927796093eb">
+      <Terms xmlns="http://schemas.microsoft.com/office/infopath/2007/PartnerControls"/>
+    </lcf76f155ced4ddcb4097134ff3c332f>
+    <TaxCatchAll xmlns="9bed8fe0-fd4c-4f92-9936-a2497f3396f6" xsi:nil="true"/>
+  </documentManagement>
+</p:properties>
 </file>
 
-<file path=customXml/itemProps2.xml><?xml version="1.0" encoding="utf-8"?>
-<ds:datastoreItem xmlns:ds="http://schemas.openxmlformats.org/officeDocument/2006/customXml" ds:itemID="{746C92BA-2C15-4648-8094-8AE24EF764A2}">
-  <ds:schemaRefs>
-    <ds:schemaRef ds:uri="http://schemas.microsoft.com/office/2006/metadata/properties"/>
-    <ds:schemaRef ds:uri="http://schemas.microsoft.com/office/infopath/2007/PartnerControls"/>
-    <ds:schemaRef ds:uri="5d8f0207-1964-4a5e-9049-2927796093eb"/>
-    <ds:schemaRef ds:uri="9bed8fe0-fd4c-4f92-9936-a2497f3396f6"/>
-  </ds:schemaRefs>
-</ds:datastoreItem>
+<file path=customXml/item3.xml><?xml version="1.0" encoding="utf-8"?>
+<?mso-contentType ?>
+<FormTemplates xmlns="http://schemas.microsoft.com/sharepoint/v3/contenttype/forms">
+  <Display>DocumentLibraryForm</Display>
+  <Edit>DocumentLibraryForm</Edit>
+  <New>DocumentLibraryForm</New>
+</FormTemplates>
 </file>
 
-<file path=customXml/itemProps3.xml><?xml version="1.0" encoding="utf-8"?>
+<file path=customXml/itemProps1.xml><?xml version="1.0" encoding="utf-8"?>
 <ds:datastoreItem xmlns:ds="http://schemas.openxmlformats.org/officeDocument/2006/customXml" ds:itemID="{9796CB3A-B122-4517-855C-0F4A88E980E9}">
   <ds:schemaRefs>
     <ds:schemaRef ds:uri="http://schemas.microsoft.com/office/2006/metadata/contentType"/>
@@ -13029,6 +13795,25 @@
 </ds:datastoreItem>
 </file>
 
+<file path=customXml/itemProps2.xml><?xml version="1.0" encoding="utf-8"?>
+<ds:datastoreItem xmlns:ds="http://schemas.openxmlformats.org/officeDocument/2006/customXml" ds:itemID="{746C92BA-2C15-4648-8094-8AE24EF764A2}">
+  <ds:schemaRefs>
+    <ds:schemaRef ds:uri="http://schemas.microsoft.com/office/2006/metadata/properties"/>
+    <ds:schemaRef ds:uri="http://schemas.microsoft.com/office/infopath/2007/PartnerControls"/>
+    <ds:schemaRef ds:uri="5d8f0207-1964-4a5e-9049-2927796093eb"/>
+    <ds:schemaRef ds:uri="9bed8fe0-fd4c-4f92-9936-a2497f3396f6"/>
+  </ds:schemaRefs>
+</ds:datastoreItem>
+</file>
+
+<file path=customXml/itemProps3.xml><?xml version="1.0" encoding="utf-8"?>
+<ds:datastoreItem xmlns:ds="http://schemas.openxmlformats.org/officeDocument/2006/customXml" ds:itemID="{87F4C4DB-07ED-49AD-9A79-4094EE45E6E4}">
+  <ds:schemaRefs>
+    <ds:schemaRef ds:uri="http://schemas.microsoft.com/sharepoint/v3/contenttype/forms"/>
+  </ds:schemaRefs>
+</ds:datastoreItem>
+</file>
+
 <file path=docMetadata/LabelInfo.xml><?xml version="1.0" encoding="utf-8"?>
 <clbl:labelList xmlns:clbl="http://schemas.microsoft.com/office/2020/mipLabelMetadata">
   <clbl:label id="{723a5a87-f39a-4a22-9247-3fc240c01396}" enabled="0" method="" siteId="{723a5a87-f39a-4a22-9247-3fc240c01396}" removed="1"/>

</xml_diff>